<commit_message>
ctl.mjs unregister: stop sending to the panel, keep the local data (D-34)
- unregister deletes the credential and the events still waiting to leave, and records unregistered_at; the local
  book stays (the missions and /missions keep working). Nothing more can be sent.
- register refuses without --again (exit 6), so the setup's step 8 never brings the person back; the installer keeps
  unregistered_at on a reinstall of the same workshop; --check / -Check no longer asks to register (E-TEL-04).
- The command is on the Project 2 opening slide as optional (pt, en) and in PRIVACY.md (en, pt). Code blocks in the
  v2 deck now simulate word wrapping; panel slides sit lower under a two-line title.
- Tests: an end-to-end test against the local server, the installer, the Mac setup and Pester.

Co-Authored-By: Claude Opus 5.5 <noreply@anthropic.com>
</commit_message>
<xml_diff>
--- a/slides/workshop-v2.en.pptx
+++ b/slides/workshop-v2.en.pptx
@@ -138,7 +138,7 @@
   <p:extLst>
     <p:ext uri="{521415D9-36F7-43E2-AB2F-B90AF26B5E84}">
       <p14:sectionLst xmlns:p14="http://schemas.microsoft.com/office/powerpoint/2010/main">
-        <p14:section name="Opening" id="{787457e5-ec8d-16e1-04aa-7a696554cada}">
+        <p14:section name="Opening" id="{e3b43215-1298-1aa3-cb79-4f8abb8cae52}">
           <p14:sldIdLst>
             <p14:sldId id="256"/>
             <p14:sldId id="257"/>
@@ -149,7 +149,7 @@
             <p14:sldId id="262"/>
           </p14:sldIdLst>
         </p14:section>
-        <p14:section name="Missions" id="{74edead9-fa3f-a2e2-f1a1-7cc16f15b25f}">
+        <p14:section name="Missions" id="{348f2a70-df19-93b6-266e-4415cb2ed57a}">
           <p14:sldIdLst>
             <p14:sldId id="263"/>
             <p14:sldId id="264"/>
@@ -161,7 +161,7 @@
             <p14:sldId id="270"/>
           </p14:sldIdLst>
         </p14:section>
-        <p14:section name="Project 1" id="{dfee0db5-5cf4-8c67-a702-8567a23432ae}">
+        <p14:section name="Project 1" id="{9f3d4d78-5398-5566-64b2-3207c5b39fc1}">
           <p14:sldIdLst>
             <p14:sldId id="271"/>
             <p14:sldId id="272"/>
@@ -173,7 +173,7 @@
             <p14:sldId id="278"/>
           </p14:sldIdLst>
         </p14:section>
-        <p14:section name="Project 2" id="{386aff5a-0c68-8c53-f7e5-6575983a44f9}">
+        <p14:section name="Project 2" id="{efb1dfe3-eb69-d413-050a-74f5087fdecc}">
           <p14:sldIdLst>
             <p14:sldId id="279"/>
             <p14:sldId id="280"/>
@@ -184,7 +184,7 @@
             <p14:sldId id="285"/>
           </p14:sldIdLst>
         </p14:section>
-        <p14:section name="Closing" id="{4879fded-ab05-5213-5a14-3afa10a89aa9}">
+        <p14:section name="Closing" id="{c69d2b15-dd49-a714-e9ed-6042f01cbfa6}">
           <p14:sldIdLst>
             <p14:sldId id="286"/>
             <p14:sldId id="287"/>
@@ -2153,6 +2153,7 @@
 - The default path is the Municipal Library, with no login; whoever has Jira or GitHub working can use their own issue.
 Look at the panel:
 - The funnel is empty: "in 30 minutes we want the whole room at the end".
+- Whoever will work in their own repository and prefers that nothing leaves the laptop: "unregister stops the sending; your mission book stays, and register --again turns it back on".
 Clock: you should be here at 50 min.</a:t>
             </a:r>
             <a:endParaRPr lang="en-US" dirty="0"/>
@@ -5935,7 +5936,7 @@
         <p:spPr>
           <a:xfrm>
             <a:off x="640080" y="5989320"/>
-            <a:ext cx="10911535" cy="1954073"/>
+            <a:ext cx="10911535" cy="1561795"/>
           </a:xfrm>
           <a:prstGeom prst="rect">
             <a:avLst/>
@@ -5999,7 +6000,7 @@
         <p:spPr>
           <a:xfrm>
             <a:off x="914400" y="6629400"/>
-            <a:ext cx="10362895" cy="1176833"/>
+            <a:ext cx="10362895" cy="784555"/>
           </a:xfrm>
           <a:prstGeom prst="rect">
             <a:avLst/>
@@ -6015,7 +6016,7 @@
               <a:buNone/>
             </a:pPr>
             <a:r>
-              <a:rPr lang="en-US" sz="2200" dirty="0">
+              <a:rPr lang="en-US" sz="2100" dirty="0">
                 <a:solidFill>
                   <a:srgbClr val="FCF9FE"/>
                 </a:solidFill>
@@ -6025,7 +6026,7 @@
               </a:rPr>
               <a:t>Use an Explore subagent to list the functions in src/units.js that have no test.</a:t>
             </a:r>
-            <a:endParaRPr lang="en-US" sz="2200" dirty="0"/>
+            <a:endParaRPr lang="en-US" sz="2100" dirty="0"/>
           </a:p>
         </p:txBody>
       </p:sp>
@@ -6802,7 +6803,7 @@
               <a:buNone/>
             </a:pPr>
             <a:r>
-              <a:rPr lang="en-US" sz="2000" dirty="0">
+              <a:rPr lang="en-US" sz="2100" dirty="0">
                 <a:solidFill>
                   <a:srgbClr val="FCF9FE"/>
                 </a:solidFill>
@@ -6812,14 +6813,14 @@
               </a:rPr>
               <a:t>Create .claude/skills/summary/SKILL.md: summarise a file in 3 lines</a:t>
             </a:r>
-            <a:endParaRPr lang="en-US" sz="2000" dirty="0"/>
-          </a:p>
-          <a:p>
-            <a:pPr indent="0" marL="0">
-              <a:buNone/>
-            </a:pPr>
-            <a:r>
-              <a:rPr lang="en-US" sz="2000" dirty="0">
+            <a:endParaRPr lang="en-US" sz="2100" dirty="0"/>
+          </a:p>
+          <a:p>
+            <a:pPr indent="0" marL="0">
+              <a:buNone/>
+            </a:pPr>
+            <a:r>
+              <a:rPr lang="en-US" sz="2100" dirty="0">
                 <a:solidFill>
                   <a:srgbClr val="FCF9FE"/>
                 </a:solidFill>
@@ -6829,14 +6830,14 @@
               </a:rPr>
               <a:t>/exit</a:t>
             </a:r>
-            <a:endParaRPr lang="en-US" sz="2000" dirty="0"/>
-          </a:p>
-          <a:p>
-            <a:pPr indent="0" marL="0">
-              <a:buNone/>
-            </a:pPr>
-            <a:r>
-              <a:rPr lang="en-US" sz="2000" dirty="0">
+            <a:endParaRPr lang="en-US" sz="2100" dirty="0"/>
+          </a:p>
+          <a:p>
+            <a:pPr indent="0" marL="0">
+              <a:buNone/>
+            </a:pPr>
+            <a:r>
+              <a:rPr lang="en-US" sz="2100" dirty="0">
                 <a:solidFill>
                   <a:srgbClr val="FCF9FE"/>
                 </a:solidFill>
@@ -6846,14 +6847,14 @@
               </a:rPr>
               <a:t>claude -c</a:t>
             </a:r>
-            <a:endParaRPr lang="en-US" sz="2000" dirty="0"/>
-          </a:p>
-          <a:p>
-            <a:pPr indent="0" marL="0">
-              <a:buNone/>
-            </a:pPr>
-            <a:r>
-              <a:rPr lang="en-US" sz="2000" dirty="0">
+            <a:endParaRPr lang="en-US" sz="2100" dirty="0"/>
+          </a:p>
+          <a:p>
+            <a:pPr indent="0" marL="0">
+              <a:buNone/>
+            </a:pPr>
+            <a:r>
+              <a:rPr lang="en-US" sz="2100" dirty="0">
                 <a:solidFill>
                   <a:srgbClr val="FCF9FE"/>
                 </a:solidFill>
@@ -6863,7 +6864,7 @@
               </a:rPr>
               <a:t>/summary src/units.js</a:t>
             </a:r>
-            <a:endParaRPr lang="en-US" sz="2000" dirty="0"/>
+            <a:endParaRPr lang="en-US" sz="2100" dirty="0"/>
           </a:p>
         </p:txBody>
       </p:sp>
@@ -8364,7 +8365,7 @@
         <p:spPr>
           <a:xfrm>
             <a:off x="640080" y="5989320"/>
-            <a:ext cx="10911535" cy="1954073"/>
+            <a:ext cx="10911535" cy="1561795"/>
           </a:xfrm>
           <a:prstGeom prst="rect">
             <a:avLst/>
@@ -8428,7 +8429,7 @@
         <p:spPr>
           <a:xfrm>
             <a:off x="914400" y="6629400"/>
-            <a:ext cx="10362895" cy="1176833"/>
+            <a:ext cx="10362895" cy="784555"/>
           </a:xfrm>
           <a:prstGeom prst="rect">
             <a:avLst/>
@@ -8444,7 +8445,7 @@
               <a:buNone/>
             </a:pPr>
             <a:r>
-              <a:rPr lang="en-US" sz="2200" dirty="0">
+              <a:rPr lang="en-US" sz="2100" dirty="0">
                 <a:solidFill>
                   <a:srgbClr val="FCF9FE"/>
                 </a:solidFill>
@@ -8454,7 +8455,7 @@
               </a:rPr>
               <a:t>/loop 1m run npm test and fix the first red test; when everything is green, stop the loop</a:t>
             </a:r>
-            <a:endParaRPr lang="en-US" sz="2200" dirty="0"/>
+            <a:endParaRPr lang="en-US" sz="2100" dirty="0"/>
           </a:p>
         </p:txBody>
       </p:sp>
@@ -8785,7 +8786,7 @@
         </p:nvSpPr>
         <p:spPr>
           <a:xfrm>
-            <a:off x="640080" y="2651760"/>
+            <a:off x="640080" y="2834640"/>
             <a:ext cx="8899855" cy="2377440"/>
           </a:xfrm>
           <a:prstGeom prst="rect">
@@ -8824,7 +8825,7 @@
         </p:nvSpPr>
         <p:spPr>
           <a:xfrm>
-            <a:off x="10271455" y="2697480"/>
+            <a:off x="10271455" y="2880360"/>
             <a:ext cx="1280160" cy="1280160"/>
           </a:xfrm>
           <a:prstGeom prst="ellipse">
@@ -8857,7 +8858,7 @@
         </p:blipFill>
         <p:spPr>
           <a:xfrm>
-            <a:off x="10553090" y="2979115"/>
+            <a:off x="10553090" y="3161995"/>
             <a:ext cx="716890" cy="716890"/>
           </a:xfrm>
           <a:prstGeom prst="rect">
@@ -8873,7 +8874,7 @@
         </p:nvSpPr>
         <p:spPr>
           <a:xfrm>
-            <a:off x="9539935" y="4069080"/>
+            <a:off x="9539935" y="4251960"/>
             <a:ext cx="2011680" cy="822960"/>
           </a:xfrm>
           <a:prstGeom prst="rect">
@@ -8912,7 +8913,7 @@
         </p:nvSpPr>
         <p:spPr>
           <a:xfrm>
-            <a:off x="640080" y="5303520"/>
+            <a:off x="640080" y="5394960"/>
             <a:ext cx="8899855" cy="950976"/>
           </a:xfrm>
           <a:prstGeom prst="rect">
@@ -8952,7 +8953,7 @@
         <p:spPr>
           <a:xfrm>
             <a:off x="640080" y="6574536"/>
-            <a:ext cx="10911535" cy="2903220"/>
+            <a:ext cx="10911535" cy="2738628"/>
           </a:xfrm>
           <a:prstGeom prst="rect">
             <a:avLst/>
@@ -9016,7 +9017,7 @@
         <p:spPr>
           <a:xfrm>
             <a:off x="914400" y="7214616"/>
-            <a:ext cx="10362895" cy="2125980"/>
+            <a:ext cx="10362895" cy="1961388"/>
           </a:xfrm>
           <a:prstGeom prst="rect">
             <a:avLst/>
@@ -9032,7 +9033,7 @@
               <a:buNone/>
             </a:pPr>
             <a:r>
-              <a:rPr lang="en-US" sz="2100" dirty="0">
+              <a:rPr lang="en-US" sz="2200" dirty="0">
                 <a:solidFill>
                   <a:srgbClr val="FCF9FE"/>
                 </a:solidFill>
@@ -9042,14 +9043,14 @@
               </a:rPr>
               <a:t>M7  /btw what is a subagent?   (a tip, not checked)</a:t>
             </a:r>
-            <a:endParaRPr lang="en-US" sz="2100" dirty="0"/>
-          </a:p>
-          <a:p>
-            <a:pPr indent="0" marL="0">
-              <a:buNone/>
-            </a:pPr>
-            <a:r>
-              <a:rPr lang="en-US" sz="2100" dirty="0">
+            <a:endParaRPr lang="en-US" sz="2200" dirty="0"/>
+          </a:p>
+          <a:p>
+            <a:pPr indent="0" marL="0">
+              <a:buNone/>
+            </a:pPr>
+            <a:r>
+              <a:rPr lang="en-US" sz="2200" dirty="0">
                 <a:solidFill>
                   <a:srgbClr val="FCF9FE"/>
                 </a:solidFill>
@@ -9059,14 +9060,14 @@
               </a:rPr>
               <a:t>M8  /statusline show the model and the branch</a:t>
             </a:r>
-            <a:endParaRPr lang="en-US" sz="2100" dirty="0"/>
-          </a:p>
-          <a:p>
-            <a:pPr indent="0" marL="0">
-              <a:buNone/>
-            </a:pPr>
-            <a:r>
-              <a:rPr lang="en-US" sz="2100" dirty="0">
+            <a:endParaRPr lang="en-US" sz="2200" dirty="0"/>
+          </a:p>
+          <a:p>
+            <a:pPr indent="0" marL="0">
+              <a:buNone/>
+            </a:pPr>
+            <a:r>
+              <a:rPr lang="en-US" sz="2200" dirty="0">
                 <a:solidFill>
                   <a:srgbClr val="FCF9FE"/>
                 </a:solidFill>
@@ -9076,14 +9077,14 @@
               </a:rPr>
               <a:t>M9  claude -p "Summarise the README" --model haiku &gt; summary.txt</a:t>
             </a:r>
-            <a:endParaRPr lang="en-US" sz="2100" dirty="0"/>
-          </a:p>
-          <a:p>
-            <a:pPr indent="0" marL="0">
-              <a:buNone/>
-            </a:pPr>
-            <a:r>
-              <a:rPr lang="en-US" sz="2100" dirty="0">
+            <a:endParaRPr lang="en-US" sz="2200" dirty="0"/>
+          </a:p>
+          <a:p>
+            <a:pPr indent="0" marL="0">
+              <a:buNone/>
+            </a:pPr>
+            <a:r>
+              <a:rPr lang="en-US" sz="2200" dirty="0">
                 <a:solidFill>
                   <a:srgbClr val="FCF9FE"/>
                 </a:solidFill>
@@ -9093,7 +9094,7 @@
               </a:rPr>
               <a:t>M10 /memory save a lesson about the converter</a:t>
             </a:r>
-            <a:endParaRPr lang="en-US" sz="2100" dirty="0"/>
+            <a:endParaRPr lang="en-US" sz="2200" dirty="0"/>
           </a:p>
         </p:txBody>
       </p:sp>
@@ -9322,7 +9323,7 @@
         </p:nvSpPr>
         <p:spPr>
           <a:xfrm>
-            <a:off x="640080" y="2651760"/>
+            <a:off x="640080" y="2331720"/>
             <a:ext cx="8899855" cy="2377440"/>
           </a:xfrm>
           <a:prstGeom prst="rect">
@@ -9361,7 +9362,7 @@
         </p:nvSpPr>
         <p:spPr>
           <a:xfrm>
-            <a:off x="10271455" y="2697480"/>
+            <a:off x="10271455" y="2377440"/>
             <a:ext cx="1280160" cy="1280160"/>
           </a:xfrm>
           <a:prstGeom prst="ellipse">
@@ -9394,7 +9395,7 @@
         </p:blipFill>
         <p:spPr>
           <a:xfrm>
-            <a:off x="10553090" y="2979115"/>
+            <a:off x="10553090" y="2659075"/>
             <a:ext cx="716890" cy="716890"/>
           </a:xfrm>
           <a:prstGeom prst="rect">
@@ -9410,7 +9411,7 @@
         </p:nvSpPr>
         <p:spPr>
           <a:xfrm>
-            <a:off x="9539935" y="4069080"/>
+            <a:off x="9539935" y="3749040"/>
             <a:ext cx="2011680" cy="822960"/>
           </a:xfrm>
           <a:prstGeom prst="rect">
@@ -9449,7 +9450,7 @@
         </p:nvSpPr>
         <p:spPr>
           <a:xfrm>
-            <a:off x="640080" y="5303520"/>
+            <a:off x="640080" y="4892040"/>
             <a:ext cx="8899855" cy="950976"/>
           </a:xfrm>
           <a:prstGeom prst="rect">
@@ -9488,7 +9489,7 @@
         </p:nvSpPr>
         <p:spPr>
           <a:xfrm>
-            <a:off x="640080" y="6574536"/>
+            <a:off x="640080" y="6071616"/>
             <a:ext cx="10911535" cy="1561795"/>
           </a:xfrm>
           <a:prstGeom prst="rect">
@@ -9513,7 +9514,7 @@
         </p:nvSpPr>
         <p:spPr>
           <a:xfrm>
-            <a:off x="914400" y="6757416"/>
+            <a:off x="914400" y="6254496"/>
             <a:ext cx="10362895" cy="365760"/>
           </a:xfrm>
           <a:prstGeom prst="rect">
@@ -9552,7 +9553,7 @@
         </p:nvSpPr>
         <p:spPr>
           <a:xfrm>
-            <a:off x="914400" y="7214616"/>
+            <a:off x="914400" y="6711696"/>
             <a:ext cx="10362895" cy="784555"/>
           </a:xfrm>
           <a:prstGeom prst="rect">
@@ -13612,7 +13613,7 @@
         <p:spPr>
           <a:xfrm>
             <a:off x="640080" y="4535424"/>
-            <a:ext cx="5318608" cy="2738628"/>
+            <a:ext cx="5318608" cy="2346350"/>
           </a:xfrm>
           <a:prstGeom prst="rect">
             <a:avLst/>
@@ -13676,7 +13677,7 @@
         <p:spPr>
           <a:xfrm>
             <a:off x="914400" y="5175504"/>
-            <a:ext cx="4769968" cy="1961388"/>
+            <a:ext cx="4769968" cy="1569110"/>
           </a:xfrm>
           <a:prstGeom prst="rect">
             <a:avLst/>
@@ -13715,7 +13716,7 @@
         <p:spPr>
           <a:xfrm>
             <a:off x="6233008" y="4535424"/>
-            <a:ext cx="5318608" cy="2738628"/>
+            <a:ext cx="5318608" cy="2346350"/>
           </a:xfrm>
           <a:prstGeom prst="rect">
             <a:avLst/>
@@ -13779,7 +13780,7 @@
         <p:spPr>
           <a:xfrm>
             <a:off x="6507328" y="5175504"/>
-            <a:ext cx="4769968" cy="1961388"/>
+            <a:ext cx="4769968" cy="1569110"/>
           </a:xfrm>
           <a:prstGeom prst="rect">
             <a:avLst/>
@@ -13795,7 +13796,7 @@
               <a:buNone/>
             </a:pPr>
             <a:r>
-              <a:rPr lang="en-US" sz="2200" dirty="0">
+              <a:rPr lang="en-US" sz="2100" dirty="0">
                 <a:solidFill>
                   <a:srgbClr val="FCF9FE"/>
                 </a:solidFill>
@@ -13805,14 +13806,14 @@
               </a:rPr>
               <a:t>cd ~/workshop-claude/canivete-project</a:t>
             </a:r>
-            <a:endParaRPr lang="en-US" sz="2200" dirty="0"/>
-          </a:p>
-          <a:p>
-            <a:pPr indent="0" marL="0">
-              <a:buNone/>
-            </a:pPr>
-            <a:r>
-              <a:rPr lang="en-US" sz="2200" dirty="0">
+            <a:endParaRPr lang="en-US" sz="2100" dirty="0"/>
+          </a:p>
+          <a:p>
+            <a:pPr indent="0" marL="0">
+              <a:buNone/>
+            </a:pPr>
+            <a:r>
+              <a:rPr lang="en-US" sz="2100" dirty="0">
                 <a:solidFill>
                   <a:srgbClr val="FCF9FE"/>
                 </a:solidFill>
@@ -13822,14 +13823,14 @@
               </a:rPr>
               <a:t>node server.js</a:t>
             </a:r>
-            <a:endParaRPr lang="en-US" sz="2200" dirty="0"/>
-          </a:p>
-          <a:p>
-            <a:pPr indent="0" marL="0">
-              <a:buNone/>
-            </a:pPr>
-            <a:r>
-              <a:rPr lang="en-US" sz="2200" dirty="0">
+            <a:endParaRPr lang="en-US" sz="2100" dirty="0"/>
+          </a:p>
+          <a:p>
+            <a:pPr indent="0" marL="0">
+              <a:buNone/>
+            </a:pPr>
+            <a:r>
+              <a:rPr lang="en-US" sz="2100" dirty="0">
                 <a:solidFill>
                   <a:srgbClr val="FCF9FE"/>
                 </a:solidFill>
@@ -13839,7 +13840,7 @@
               </a:rPr>
               <a:t>http://localhost:3000/status</a:t>
             </a:r>
-            <a:endParaRPr lang="en-US" sz="2200" dirty="0"/>
+            <a:endParaRPr lang="en-US" sz="2100" dirty="0"/>
           </a:p>
         </p:txBody>
       </p:sp>
@@ -14536,7 +14537,7 @@
         <p:spPr>
           <a:xfrm>
             <a:off x="640080" y="4535424"/>
-            <a:ext cx="5318608" cy="2346350"/>
+            <a:ext cx="5318608" cy="1954073"/>
           </a:xfrm>
           <a:prstGeom prst="rect">
             <a:avLst/>
@@ -14600,7 +14601,7 @@
         <p:spPr>
           <a:xfrm>
             <a:off x="914400" y="5175504"/>
-            <a:ext cx="4769968" cy="1569110"/>
+            <a:ext cx="4769968" cy="1176833"/>
           </a:xfrm>
           <a:prstGeom prst="rect">
             <a:avLst/>
@@ -14639,7 +14640,7 @@
         <p:spPr>
           <a:xfrm>
             <a:off x="6233008" y="4535424"/>
-            <a:ext cx="5318608" cy="2346350"/>
+            <a:ext cx="5318608" cy="1954073"/>
           </a:xfrm>
           <a:prstGeom prst="rect">
             <a:avLst/>
@@ -14703,7 +14704,7 @@
         <p:spPr>
           <a:xfrm>
             <a:off x="6507328" y="5175504"/>
-            <a:ext cx="4769968" cy="1569110"/>
+            <a:ext cx="4769968" cy="1176833"/>
           </a:xfrm>
           <a:prstGeom prst="rect">
             <a:avLst/>
@@ -14719,7 +14720,7 @@
               <a:buNone/>
             </a:pPr>
             <a:r>
-              <a:rPr lang="en-US" sz="2100" dirty="0">
+              <a:rPr lang="en-US" sz="2200" dirty="0">
                 <a:solidFill>
                   <a:srgbClr val="FCF9FE"/>
                 </a:solidFill>
@@ -14729,14 +14730,14 @@
               </a:rPr>
               <a:t>tools/nm-03/spec.md   (add the rule)</a:t>
             </a:r>
-            <a:endParaRPr lang="en-US" sz="2100" dirty="0"/>
-          </a:p>
-          <a:p>
-            <a:pPr indent="0" marL="0">
-              <a:buNone/>
-            </a:pPr>
-            <a:r>
-              <a:rPr lang="en-US" sz="2100" dirty="0">
+            <a:endParaRPr lang="en-US" sz="2200" dirty="0"/>
+          </a:p>
+          <a:p>
+            <a:pPr indent="0" marL="0">
+              <a:buNone/>
+            </a:pPr>
+            <a:r>
+              <a:rPr lang="en-US" sz="2200" dirty="0">
                 <a:solidFill>
                   <a:srgbClr val="FCF9FE"/>
                 </a:solidFill>
@@ -14746,7 +14747,7 @@
               </a:rPr>
               <a:t>/demo-swarm --retry nm-03</a:t>
             </a:r>
-            <a:endParaRPr lang="en-US" sz="2100" dirty="0"/>
+            <a:endParaRPr lang="en-US" sz="2200" dirty="0"/>
           </a:p>
         </p:txBody>
       </p:sp>
@@ -16619,7 +16620,7 @@
         </p:nvSpPr>
         <p:spPr>
           <a:xfrm>
-            <a:off x="640080" y="2651760"/>
+            <a:off x="640080" y="2331720"/>
             <a:ext cx="8899855" cy="1645920"/>
           </a:xfrm>
           <a:prstGeom prst="rect">
@@ -16658,7 +16659,7 @@
         </p:nvSpPr>
         <p:spPr>
           <a:xfrm>
-            <a:off x="10271455" y="2697480"/>
+            <a:off x="10271455" y="2377440"/>
             <a:ext cx="1280160" cy="1280160"/>
           </a:xfrm>
           <a:prstGeom prst="ellipse">
@@ -16691,7 +16692,7 @@
         </p:blipFill>
         <p:spPr>
           <a:xfrm>
-            <a:off x="10553090" y="2979115"/>
+            <a:off x="10553090" y="2659075"/>
             <a:ext cx="716890" cy="716890"/>
           </a:xfrm>
           <a:prstGeom prst="rect">
@@ -16707,7 +16708,7 @@
         </p:nvSpPr>
         <p:spPr>
           <a:xfrm>
-            <a:off x="9539935" y="4069080"/>
+            <a:off x="9539935" y="3749040"/>
             <a:ext cx="2011680" cy="822960"/>
           </a:xfrm>
           <a:prstGeom prst="rect">
@@ -16746,7 +16747,7 @@
         </p:nvSpPr>
         <p:spPr>
           <a:xfrm>
-            <a:off x="640080" y="4572000"/>
+            <a:off x="640080" y="4160520"/>
             <a:ext cx="8899855" cy="1380744"/>
           </a:xfrm>
           <a:prstGeom prst="rect">
@@ -16785,7 +16786,7 @@
         </p:nvSpPr>
         <p:spPr>
           <a:xfrm>
-            <a:off x="640080" y="6272784"/>
+            <a:off x="640080" y="5769864"/>
             <a:ext cx="10911535" cy="1561795"/>
           </a:xfrm>
           <a:prstGeom prst="rect">
@@ -16810,7 +16811,7 @@
         </p:nvSpPr>
         <p:spPr>
           <a:xfrm>
-            <a:off x="914400" y="6455664"/>
+            <a:off x="914400" y="5952744"/>
             <a:ext cx="10362895" cy="365760"/>
           </a:xfrm>
           <a:prstGeom prst="rect">
@@ -16849,7 +16850,7 @@
         </p:nvSpPr>
         <p:spPr>
           <a:xfrm>
-            <a:off x="914400" y="6912864"/>
+            <a:off x="914400" y="6409944"/>
             <a:ext cx="10362895" cy="784555"/>
           </a:xfrm>
           <a:prstGeom prst="rect">
@@ -16894,6 +16895,126 @@
               <a:t>claude</a:t>
             </a:r>
             <a:endParaRPr lang="en-US" sz="2100" dirty="0"/>
+          </a:p>
+        </p:txBody>
+      </p:sp>
+      <p:sp>
+        <p:nvSpPr>
+          <p:cNvPr id="14" name="code-background"/>
+          <p:cNvSpPr/>
+          <p:nvPr/>
+        </p:nvSpPr>
+        <p:spPr>
+          <a:xfrm>
+            <a:off x="640080" y="7560259"/>
+            <a:ext cx="10911535" cy="1561795"/>
+          </a:xfrm>
+          <a:prstGeom prst="rect">
+            <a:avLst/>
+          </a:prstGeom>
+          <a:solidFill>
+            <a:srgbClr val="140920"/>
+          </a:solidFill>
+          <a:ln w="12700">
+            <a:solidFill>
+              <a:srgbClr val="140920"/>
+            </a:solidFill>
+            <a:prstDash val="solid"/>
+          </a:ln>
+        </p:spPr>
+      </p:sp>
+      <p:sp>
+        <p:nvSpPr>
+          <p:cNvPr id="15" name="code-label"/>
+          <p:cNvSpPr txBox="1"/>
+          <p:nvPr/>
+        </p:nvSpPr>
+        <p:spPr>
+          <a:xfrm>
+            <a:off x="914400" y="7743139"/>
+            <a:ext cx="10362895" cy="365760"/>
+          </a:xfrm>
+          <a:prstGeom prst="rect">
+            <a:avLst/>
+          </a:prstGeom>
+          <a:noFill/>
+          <a:ln/>
+        </p:spPr>
+        <p:txBody>
+          <a:bodyPr wrap="square" lIns="0" tIns="0" rIns="0" bIns="0" rtlCol="0" anchor="t"/>
+          <a:lstStyle/>
+          <a:p>
+            <a:pPr indent="0" marL="0">
+              <a:buNone/>
+            </a:pPr>
+            <a:r>
+              <a:rPr lang="en-US" sz="2000" b="1" dirty="0">
+                <a:solidFill>
+                  <a:srgbClr val="93A7FF"/>
+                </a:solidFill>
+                <a:latin typeface="Arial" pitchFamily="34" charset="0"/>
+                <a:ea typeface="Arial" pitchFamily="34" charset="-122"/>
+                <a:cs typeface="Arial" pitchFamily="34" charset="-120"/>
+              </a:rPr>
+              <a:t>Optional · stop sending to the panel</a:t>
+            </a:r>
+            <a:endParaRPr lang="en-US" sz="2000" dirty="0"/>
+          </a:p>
+        </p:txBody>
+      </p:sp>
+      <p:sp>
+        <p:nvSpPr>
+          <p:cNvPr id="16" name="code"/>
+          <p:cNvSpPr txBox="1"/>
+          <p:nvPr/>
+        </p:nvSpPr>
+        <p:spPr>
+          <a:xfrm>
+            <a:off x="914400" y="8200339"/>
+            <a:ext cx="10362895" cy="784555"/>
+          </a:xfrm>
+          <a:prstGeom prst="rect">
+            <a:avLst/>
+          </a:prstGeom>
+          <a:noFill/>
+          <a:ln/>
+        </p:spPr>
+        <p:txBody>
+          <a:bodyPr wrap="square" lIns="0" tIns="0" rIns="0" bIns="0" rtlCol="0" anchor="t"/>
+          <a:lstStyle/>
+          <a:p>
+            <a:pPr indent="0" marL="0">
+              <a:buNone/>
+            </a:pPr>
+            <a:r>
+              <a:rPr lang="en-US" sz="2200" dirty="0">
+                <a:solidFill>
+                  <a:srgbClr val="FCF9FE"/>
+                </a:solidFill>
+                <a:latin typeface="Courier New" pitchFamily="34" charset="0"/>
+                <a:ea typeface="Courier New" pitchFamily="34" charset="-122"/>
+                <a:cs typeface="Courier New" pitchFamily="34" charset="-120"/>
+              </a:rPr>
+              <a:t>cd "$HOME/.workshop-claude/kit/telemetry"</a:t>
+            </a:r>
+            <a:endParaRPr lang="en-US" sz="2200" dirty="0"/>
+          </a:p>
+          <a:p>
+            <a:pPr indent="0" marL="0">
+              <a:buNone/>
+            </a:pPr>
+            <a:r>
+              <a:rPr lang="en-US" sz="2200" dirty="0">
+                <a:solidFill>
+                  <a:srgbClr val="FCF9FE"/>
+                </a:solidFill>
+                <a:latin typeface="Courier New" pitchFamily="34" charset="0"/>
+                <a:ea typeface="Courier New" pitchFamily="34" charset="-122"/>
+                <a:cs typeface="Courier New" pitchFamily="34" charset="-120"/>
+              </a:rPr>
+              <a:t>node ctl.mjs unregister</a:t>
+            </a:r>
+            <a:endParaRPr lang="en-US" sz="2200" dirty="0"/>
           </a:p>
         </p:txBody>
       </p:sp>
@@ -17375,7 +17496,7 @@
         <p:spPr>
           <a:xfrm>
             <a:off x="640080" y="4535424"/>
-            <a:ext cx="5318608" cy="1954073"/>
+            <a:ext cx="5318608" cy="1561795"/>
           </a:xfrm>
           <a:prstGeom prst="rect">
             <a:avLst/>
@@ -17439,7 +17560,7 @@
         <p:spPr>
           <a:xfrm>
             <a:off x="914400" y="5175504"/>
-            <a:ext cx="4769968" cy="1176833"/>
+            <a:ext cx="4769968" cy="784555"/>
           </a:xfrm>
           <a:prstGeom prst="rect">
             <a:avLst/>
@@ -17455,7 +17576,7 @@
               <a:buNone/>
             </a:pPr>
             <a:r>
-              <a:rPr lang="en-US" sz="2200" dirty="0">
+              <a:rPr lang="en-US" sz="2100" dirty="0">
                 <a:solidFill>
                   <a:srgbClr val="FCF9FE"/>
                 </a:solidFill>
@@ -17465,7 +17586,7 @@
               </a:rPr>
               <a:t>/task-intake issues/EX-1.json</a:t>
             </a:r>
-            <a:endParaRPr lang="en-US" sz="2200" dirty="0"/>
+            <a:endParaRPr lang="en-US" sz="2100" dirty="0"/>
           </a:p>
         </p:txBody>
       </p:sp>
@@ -17478,7 +17599,7 @@
         <p:spPr>
           <a:xfrm>
             <a:off x="6233008" y="4535424"/>
-            <a:ext cx="5318608" cy="1954073"/>
+            <a:ext cx="5318608" cy="1561795"/>
           </a:xfrm>
           <a:prstGeom prst="rect">
             <a:avLst/>
@@ -17542,7 +17663,7 @@
         <p:spPr>
           <a:xfrm>
             <a:off x="6507328" y="5175504"/>
-            <a:ext cx="4769968" cy="1176833"/>
+            <a:ext cx="4769968" cy="784555"/>
           </a:xfrm>
           <a:prstGeom prst="rect">
             <a:avLst/>
@@ -22629,7 +22750,7 @@
         </p:nvSpPr>
         <p:spPr>
           <a:xfrm>
-            <a:off x="640080" y="2651760"/>
+            <a:off x="640080" y="2834640"/>
             <a:ext cx="8899855" cy="2377440"/>
           </a:xfrm>
           <a:prstGeom prst="rect">
@@ -22668,7 +22789,7 @@
         </p:nvSpPr>
         <p:spPr>
           <a:xfrm>
-            <a:off x="10271455" y="2697480"/>
+            <a:off x="10271455" y="2880360"/>
             <a:ext cx="1280160" cy="1280160"/>
           </a:xfrm>
           <a:prstGeom prst="ellipse">
@@ -22701,7 +22822,7 @@
         </p:blipFill>
         <p:spPr>
           <a:xfrm>
-            <a:off x="10553090" y="2979115"/>
+            <a:off x="10553090" y="3161995"/>
             <a:ext cx="716890" cy="716890"/>
           </a:xfrm>
           <a:prstGeom prst="rect">
@@ -22717,7 +22838,7 @@
         </p:nvSpPr>
         <p:spPr>
           <a:xfrm>
-            <a:off x="9539935" y="4069080"/>
+            <a:off x="9539935" y="4251960"/>
             <a:ext cx="2011680" cy="822960"/>
           </a:xfrm>
           <a:prstGeom prst="rect">
@@ -22756,7 +22877,7 @@
         </p:nvSpPr>
         <p:spPr>
           <a:xfrm>
-            <a:off x="640080" y="5303520"/>
+            <a:off x="640080" y="5394960"/>
             <a:ext cx="7315200" cy="502920"/>
           </a:xfrm>
           <a:prstGeom prst="rect">
@@ -22795,7 +22916,7 @@
         </p:nvSpPr>
         <p:spPr>
           <a:xfrm>
-            <a:off x="640080" y="6035040"/>
+            <a:off x="640080" y="6126480"/>
             <a:ext cx="548640" cy="548640"/>
           </a:xfrm>
           <a:prstGeom prst="ellipse">
@@ -22840,7 +22961,7 @@
         </p:nvSpPr>
         <p:spPr>
           <a:xfrm>
-            <a:off x="1417320" y="6035040"/>
+            <a:off x="1417320" y="6126480"/>
             <a:ext cx="10134295" cy="548640"/>
           </a:xfrm>
           <a:prstGeom prst="rect">
@@ -22879,7 +23000,7 @@
         </p:nvSpPr>
         <p:spPr>
           <a:xfrm>
-            <a:off x="640080" y="6903720"/>
+            <a:off x="640080" y="6995160"/>
             <a:ext cx="548640" cy="548640"/>
           </a:xfrm>
           <a:prstGeom prst="ellipse">
@@ -22924,7 +23045,7 @@
         </p:nvSpPr>
         <p:spPr>
           <a:xfrm>
-            <a:off x="1417320" y="6903720"/>
+            <a:off x="1417320" y="6995160"/>
             <a:ext cx="10134295" cy="548640"/>
           </a:xfrm>
           <a:prstGeom prst="rect">
@@ -22963,7 +23084,7 @@
         </p:nvSpPr>
         <p:spPr>
           <a:xfrm>
-            <a:off x="640080" y="7772400"/>
+            <a:off x="640080" y="7863840"/>
             <a:ext cx="548640" cy="548640"/>
           </a:xfrm>
           <a:prstGeom prst="ellipse">
@@ -23008,7 +23129,7 @@
         </p:nvSpPr>
         <p:spPr>
           <a:xfrm>
-            <a:off x="1417320" y="7772400"/>
+            <a:off x="1417320" y="7863840"/>
             <a:ext cx="10134295" cy="548640"/>
           </a:xfrm>
           <a:prstGeom prst="rect">
@@ -25260,7 +25381,7 @@
         <p:spPr>
           <a:xfrm>
             <a:off x="640080" y="5229454"/>
-            <a:ext cx="10911535" cy="1954073"/>
+            <a:ext cx="10911535" cy="1561795"/>
           </a:xfrm>
           <a:prstGeom prst="rect">
             <a:avLst/>
@@ -25324,7 +25445,7 @@
         <p:spPr>
           <a:xfrm>
             <a:off x="914400" y="5869534"/>
-            <a:ext cx="10362895" cy="1176833"/>
+            <a:ext cx="10362895" cy="784555"/>
           </a:xfrm>
           <a:prstGeom prst="rect">
             <a:avLst/>
@@ -25340,7 +25461,7 @@
               <a:buNone/>
             </a:pPr>
             <a:r>
-              <a:rPr lang="en-US" sz="2200" dirty="0">
+              <a:rPr lang="en-US" sz="2100" dirty="0">
                 <a:solidFill>
                   <a:srgbClr val="FCF9FE"/>
                 </a:solidFill>
@@ -25350,7 +25471,7 @@
               </a:rPr>
               <a:t>powershell -NoProfile -ExecutionPolicy Bypass -File "$env:USERPROFILE\.workshop-claude\setup-windows.ps1" -Check</a:t>
             </a:r>
-            <a:endParaRPr lang="en-US" sz="2200" dirty="0"/>
+            <a:endParaRPr lang="en-US" sz="2100" dirty="0"/>
           </a:p>
         </p:txBody>
       </p:sp>
@@ -25362,7 +25483,7 @@
         </p:nvSpPr>
         <p:spPr>
           <a:xfrm>
-            <a:off x="640080" y="7366406"/>
+            <a:off x="640080" y="6974129"/>
             <a:ext cx="10911535" cy="1169518"/>
           </a:xfrm>
           <a:prstGeom prst="rect">
@@ -25387,7 +25508,7 @@
         </p:nvSpPr>
         <p:spPr>
           <a:xfrm>
-            <a:off x="914400" y="7549286"/>
+            <a:off x="914400" y="7157009"/>
             <a:ext cx="10362895" cy="365760"/>
           </a:xfrm>
           <a:prstGeom prst="rect">
@@ -25426,7 +25547,7 @@
         </p:nvSpPr>
         <p:spPr>
           <a:xfrm>
-            <a:off x="914400" y="8006486"/>
+            <a:off x="914400" y="7614209"/>
             <a:ext cx="10362895" cy="392278"/>
           </a:xfrm>
           <a:prstGeom prst="rect">
@@ -25443,7 +25564,7 @@
               <a:buNone/>
             </a:pPr>
             <a:r>
-              <a:rPr lang="en-US" sz="2200" dirty="0">
+              <a:rPr lang="en-US" sz="2100" dirty="0">
                 <a:solidFill>
                   <a:srgbClr val="FCF9FE"/>
                 </a:solidFill>
@@ -25453,7 +25574,7 @@
               </a:rPr>
               <a:t>node "$HOME/.workshop-claude/kit/telemetry/ctl.mjs" register</a:t>
             </a:r>
-            <a:endParaRPr lang="en-US" sz="2200" dirty="0"/>
+            <a:endParaRPr lang="en-US" sz="2100" dirty="0"/>
           </a:p>
         </p:txBody>
       </p:sp>
@@ -25465,7 +25586,7 @@
         </p:nvSpPr>
         <p:spPr>
           <a:xfrm>
-            <a:off x="640080" y="8810244"/>
+            <a:off x="640080" y="8700516"/>
             <a:ext cx="502920" cy="502920"/>
           </a:xfrm>
           <a:prstGeom prst="ellipse">
@@ -25498,7 +25619,7 @@
         </p:blipFill>
         <p:spPr>
           <a:xfrm>
-            <a:off x="750722" y="8920886"/>
+            <a:off x="750722" y="8811158"/>
             <a:ext cx="281635" cy="281635"/>
           </a:xfrm>
           <a:prstGeom prst="rect">
@@ -25514,8 +25635,8 @@
         </p:nvSpPr>
         <p:spPr>
           <a:xfrm>
-            <a:off x="1371600" y="8764524"/>
-            <a:ext cx="10180015" cy="850392"/>
+            <a:off x="1371600" y="8654796"/>
+            <a:ext cx="10180015" cy="960120"/>
           </a:xfrm>
           <a:prstGeom prst="rect">
             <a:avLst/>
@@ -26140,7 +26261,7 @@
         <p:spPr>
           <a:xfrm>
             <a:off x="640080" y="5887822"/>
-            <a:ext cx="10911535" cy="1954073"/>
+            <a:ext cx="10911535" cy="1561795"/>
           </a:xfrm>
           <a:prstGeom prst="rect">
             <a:avLst/>
@@ -26204,7 +26325,7 @@
         <p:spPr>
           <a:xfrm>
             <a:off x="914400" y="6527902"/>
-            <a:ext cx="10362895" cy="1176833"/>
+            <a:ext cx="10362895" cy="784555"/>
           </a:xfrm>
           <a:prstGeom prst="rect">
             <a:avLst/>
@@ -26220,7 +26341,7 @@
               <a:buNone/>
             </a:pPr>
             <a:r>
-              <a:rPr lang="en-US" sz="2200" dirty="0">
+              <a:rPr lang="en-US" sz="2100" dirty="0">
                 <a:solidFill>
                   <a:srgbClr val="FCF9FE"/>
                 </a:solidFill>
@@ -26230,7 +26351,7 @@
               </a:rPr>
               <a:t>powershell -NoProfile -ExecutionPolicy Bypass -File "$env:USERPROFILE\.workshop-claude\setup-windows.ps1" -Doctor</a:t>
             </a:r>
-            <a:endParaRPr lang="en-US" sz="2200" dirty="0"/>
+            <a:endParaRPr lang="en-US" sz="2100" dirty="0"/>
           </a:p>
         </p:txBody>
       </p:sp>
@@ -26561,7 +26682,7 @@
         </p:nvSpPr>
         <p:spPr>
           <a:xfrm>
-            <a:off x="640080" y="2651760"/>
+            <a:off x="640080" y="2331720"/>
             <a:ext cx="8899855" cy="2377440"/>
           </a:xfrm>
           <a:prstGeom prst="rect">
@@ -26600,7 +26721,7 @@
         </p:nvSpPr>
         <p:spPr>
           <a:xfrm>
-            <a:off x="10271455" y="2697480"/>
+            <a:off x="10271455" y="2377440"/>
             <a:ext cx="1280160" cy="1280160"/>
           </a:xfrm>
           <a:prstGeom prst="ellipse">
@@ -26633,7 +26754,7 @@
         </p:blipFill>
         <p:spPr>
           <a:xfrm>
-            <a:off x="10553090" y="2979115"/>
+            <a:off x="10553090" y="2659075"/>
             <a:ext cx="716890" cy="716890"/>
           </a:xfrm>
           <a:prstGeom prst="rect">
@@ -26649,7 +26770,7 @@
         </p:nvSpPr>
         <p:spPr>
           <a:xfrm>
-            <a:off x="9539935" y="4069080"/>
+            <a:off x="9539935" y="3749040"/>
             <a:ext cx="2011680" cy="822960"/>
           </a:xfrm>
           <a:prstGeom prst="rect">
@@ -26688,7 +26809,7 @@
         </p:nvSpPr>
         <p:spPr>
           <a:xfrm>
-            <a:off x="640080" y="5303520"/>
+            <a:off x="640080" y="4892040"/>
             <a:ext cx="8899855" cy="950976"/>
           </a:xfrm>
           <a:prstGeom prst="rect">
@@ -26727,7 +26848,7 @@
         </p:nvSpPr>
         <p:spPr>
           <a:xfrm>
-            <a:off x="640080" y="6574536"/>
+            <a:off x="640080" y="6071616"/>
             <a:ext cx="10911535" cy="1561795"/>
           </a:xfrm>
           <a:prstGeom prst="rect">
@@ -26752,7 +26873,7 @@
         </p:nvSpPr>
         <p:spPr>
           <a:xfrm>
-            <a:off x="914400" y="6757416"/>
+            <a:off x="914400" y="6254496"/>
             <a:ext cx="10362895" cy="365760"/>
           </a:xfrm>
           <a:prstGeom prst="rect">
@@ -26791,7 +26912,7 @@
         </p:nvSpPr>
         <p:spPr>
           <a:xfrm>
-            <a:off x="914400" y="7214616"/>
+            <a:off x="914400" y="6711696"/>
             <a:ext cx="10362895" cy="784555"/>
           </a:xfrm>
           <a:prstGeom prst="rect">

</xml_diff>

<commit_message>
Panel follows the room (auto view), check_ok at install, Project 2 funnel events, /health build
- panel/aggregate.mjs: 'auto' is the default view, the block of most active people (missions, p1, p2, from each
  person's latest event); keys 1-5 force a view, POST /admin/phase {phase:'auto'} goes back; state.phase_mode;
  snapshot v3 (an old 'opening' becomes auto)
- the stage page warns in big letters on the first slide when it has no admin token
- setup (Mac and Windows): check_ok also at the end of an install without failures
- init-workshop, validate-plan and publish-text record p2_intake (origin), p2_plan (n_agents) and p2_report
  (destination); a local task gets .workshop/report.md
- /health answers {ok, build}; deploy-panel.sh passes BUILD (the commit) and checks which build answers
- chaos scenario for the auto view; a test for the Project 2 funnel

Co-Authored-By: Claude Opus 5.5 <noreply@anthropic.com>
</commit_message>
<xml_diff>
--- a/slides/workshop-v2.en.pptx
+++ b/slides/workshop-v2.en.pptx
@@ -139,7 +139,7 @@
   <p:extLst>
     <p:ext uri="{521415D9-36F7-43E2-AB2F-B90AF26B5E84}">
       <p14:sectionLst xmlns:p14="http://schemas.microsoft.com/office/powerpoint/2010/main">
-        <p14:section name="Opening" id="{dca14f00-5725-fd4a-3541-beb000b115d0}">
+        <p14:section name="Opening" id="{fc55cc71-7e6c-58a9-4531-9b16e27065d3}">
           <p14:sldIdLst>
             <p14:sldId id="256"/>
             <p14:sldId id="257"/>
@@ -150,7 +150,7 @@
             <p14:sldId id="262"/>
           </p14:sldIdLst>
         </p14:section>
-        <p14:section name="Missions" id="{3819cba7-7a3b-236f-8a92-328327105115}">
+        <p14:section name="Missions" id="{2e2a839b-d920-b333-30ed-df32f0db612b}">
           <p14:sldIdLst>
             <p14:sldId id="263"/>
             <p14:sldId id="264"/>
@@ -163,7 +163,7 @@
             <p14:sldId id="271"/>
           </p14:sldIdLst>
         </p14:section>
-        <p14:section name="Project 1" id="{0c230fc4-2bbd-c80c-8f97-7270f76125eb}">
+        <p14:section name="Project 1" id="{23e2480d-e0b2-ad03-9f28-58f1ff17cabd}">
           <p14:sldIdLst>
             <p14:sldId id="272"/>
             <p14:sldId id="273"/>
@@ -175,7 +175,7 @@
             <p14:sldId id="279"/>
           </p14:sldIdLst>
         </p14:section>
-        <p14:section name="Project 2" id="{7ac9fa77-62de-6f3c-3cb1-ecd476f548e5}">
+        <p14:section name="Project 2" id="{ca84cb2d-d28d-c13f-fa3a-c333979e3c53}">
           <p14:sldIdLst>
             <p14:sldId id="280"/>
             <p14:sldId id="281"/>
@@ -186,7 +186,7 @@
             <p14:sldId id="286"/>
           </p14:sldIdLst>
         </p14:section>
-        <p14:section name="Closing" id="{4ea157aa-0d32-0203-7812-a29cc203a9d3}">
+        <p14:section name="Closing" id="{ff2d5de3-39bc-dbec-6536-84e5dead5588}">
           <p14:sldIdLst>
             <p14:sldId id="287"/>
             <p14:sldId id="288"/>

</xml_diff>

<commit_message>
Kit v1.1.0-rc.3: M11 texts, five-laptop chaos scenario, D-37, rc.3 version and generated docs
Co-Authored-By: Claude Sonnet 5.5 <noreply@anthropic.com>
</commit_message>
<xml_diff>
--- a/slides/workshop-v2.en.pptx
+++ b/slides/workshop-v2.en.pptx
@@ -139,7 +139,7 @@
   <p:extLst>
     <p:ext uri="{521415D9-36F7-43E2-AB2F-B90AF26B5E84}">
       <p14:sectionLst xmlns:p14="http://schemas.microsoft.com/office/powerpoint/2010/main">
-        <p14:section name="Opening" id="{fc55cc71-7e6c-58a9-4531-9b16e27065d3}">
+        <p14:section name="Opening" id="{f7e47f15-e700-8fd4-608e-0eb76cc6e78c}">
           <p14:sldIdLst>
             <p14:sldId id="256"/>
             <p14:sldId id="257"/>
@@ -150,7 +150,7 @@
             <p14:sldId id="262"/>
           </p14:sldIdLst>
         </p14:section>
-        <p14:section name="Missions" id="{2e2a839b-d920-b333-30ed-df32f0db612b}">
+        <p14:section name="Missions" id="{1106807a-d6f5-dd5a-0e98-f29a04c1c278}">
           <p14:sldIdLst>
             <p14:sldId id="263"/>
             <p14:sldId id="264"/>
@@ -163,7 +163,7 @@
             <p14:sldId id="271"/>
           </p14:sldIdLst>
         </p14:section>
-        <p14:section name="Project 1" id="{23e2480d-e0b2-ad03-9f28-58f1ff17cabd}">
+        <p14:section name="Project 1" id="{8115782a-148c-8d0b-4031-698288cdd6ca}">
           <p14:sldIdLst>
             <p14:sldId id="272"/>
             <p14:sldId id="273"/>
@@ -175,7 +175,7 @@
             <p14:sldId id="279"/>
           </p14:sldIdLst>
         </p14:section>
-        <p14:section name="Project 2" id="{ca84cb2d-d28d-c13f-fa3a-c333979e3c53}">
+        <p14:section name="Project 2" id="{c79450f8-cd84-78b0-e634-dac11b463e5f}">
           <p14:sldIdLst>
             <p14:sldId id="280"/>
             <p14:sldId id="281"/>
@@ -186,7 +186,7 @@
             <p14:sldId id="286"/>
           </p14:sldIdLst>
         </p14:section>
-        <p14:section name="Closing" id="{ff2d5de3-39bc-dbec-6536-84e5dead5588}">
+        <p14:section name="Closing" id="{02a3c6c9-7184-65d9-85a9-7296c5b559dc}">
           <p14:sldIdLst>
             <p14:sldId id="287"/>
             <p14:sldId id="288"/>

</xml_diff>

<commit_message>
Pocketknife MCP: notifications/tools/list_changed when a tool.js appears, changes or goes away (M11)
Found in the 90-minute rehearsal run: the session opened before the swarm never saw the new tools (Claude Code asks
for tools/list again only after list_changed), so Claude read tool.js with cat instead of calling the tool and M11
did not count. After initialize the server looks at tools/ every 2 s (CANIVETE_MCP_POLL_MS). Checked with the real
Claude Code: a tool created mid-session shows up without a restart. The M11 slide notes (pt, en) keep /exit and
claude -c as plan B, for laptops that installed rc.3.

Co-Authored-By: Claude Opus 5.5 <noreply@anthropic.com>
</commit_message>
<xml_diff>
--- a/slides/workshop-v2.en.pptx
+++ b/slides/workshop-v2.en.pptx
@@ -139,7 +139,7 @@
   <p:extLst>
     <p:ext uri="{521415D9-36F7-43E2-AB2F-B90AF26B5E84}">
       <p14:sectionLst xmlns:p14="http://schemas.microsoft.com/office/powerpoint/2010/main">
-        <p14:section name="Opening" id="{f7e47f15-e700-8fd4-608e-0eb76cc6e78c}">
+        <p14:section name="Opening" id="{ff074d6d-d71a-7cd7-19d4-ab1a05a454cb}">
           <p14:sldIdLst>
             <p14:sldId id="256"/>
             <p14:sldId id="257"/>
@@ -150,7 +150,7 @@
             <p14:sldId id="262"/>
           </p14:sldIdLst>
         </p14:section>
-        <p14:section name="Missions" id="{1106807a-d6f5-dd5a-0e98-f29a04c1c278}">
+        <p14:section name="Missions" id="{d017ec15-5bf4-7f02-7a40-8eba5e6d79a5}">
           <p14:sldIdLst>
             <p14:sldId id="263"/>
             <p14:sldId id="264"/>
@@ -163,7 +163,7 @@
             <p14:sldId id="271"/>
           </p14:sldIdLst>
         </p14:section>
-        <p14:section name="Project 1" id="{8115782a-148c-8d0b-4031-698288cdd6ca}">
+        <p14:section name="Project 1" id="{f25c0267-858f-bb8d-9bb3-906b7e6e8871}">
           <p14:sldIdLst>
             <p14:sldId id="272"/>
             <p14:sldId id="273"/>
@@ -175,7 +175,7 @@
             <p14:sldId id="279"/>
           </p14:sldIdLst>
         </p14:section>
-        <p14:section name="Project 2" id="{c79450f8-cd84-78b0-e634-dac11b463e5f}">
+        <p14:section name="Project 2" id="{4c42cb71-c0b8-b087-654f-a3ee45428bad}">
           <p14:sldIdLst>
             <p14:sldId id="280"/>
             <p14:sldId id="281"/>
@@ -186,7 +186,7 @@
             <p14:sldId id="286"/>
           </p14:sldIdLst>
         </p14:section>
-        <p14:section name="Closing" id="{02a3c6c9-7184-65d9-85a9-7296c5b559dc}">
+        <p14:section name="Closing" id="{7d2743b2-2df2-c1eb-d3e8-3510422d72ed}">
           <p14:sldIdLst>
             <p14:sldId id="287"/>
             <p14:sldId id="288"/>
@@ -2161,8 +2161,8 @@
 Look at the panel:
 - If M11 stays low: "Claude Code must be open in the Pocketknife folder; /mcp shows whether the canivete server is connected".
 Typical failures and the answer:
-- Claude cannot find the tool → /mcp: the canivete server must be connected; reopen with claude -c
-- It answers without calling the tool → ask by name: use the my-01 tool
+- Claude cannot find the tool → /mcp: the canivete server must be connected. Plan B: /exit and claude -c, then ask again (a new session reads every tool)
+- It answers without calling the tool (it reads tool.js with cat) → ask by name: use the my-01 tool; if it still does, /exit and claude -c
 Clock: you should be here at 48 min.</a:t>
             </a:r>
             <a:endParaRPr lang="en-US" dirty="0"/>

</xml_diff>

<commit_message>
Slides: the workshop evaluation form (QR and address) on the last slide, pt and en
FEEDBACK_FORM_URL in repos.conf; the QR on a white card above the title of the closing slide, with the label and the
address; also at the end of the Teams commands file.

Co-Authored-By: Claude Opus 5.5 <noreply@anthropic.com>
</commit_message>
<xml_diff>
--- a/slides/workshop-v2.en.pptx
+++ b/slides/workshop-v2.en.pptx
@@ -139,7 +139,7 @@
   <p:extLst>
     <p:ext uri="{521415D9-36F7-43E2-AB2F-B90AF26B5E84}">
       <p14:sectionLst xmlns:p14="http://schemas.microsoft.com/office/powerpoint/2010/main">
-        <p14:section name="Opening" id="{67dde8f9-00c1-67a2-2478-b76c57866924}">
+        <p14:section name="Opening" id="{b50cb413-97f0-7479-cfe3-42ac982768dd}">
           <p14:sldIdLst>
             <p14:sldId id="256"/>
             <p14:sldId id="257"/>
@@ -150,7 +150,7 @@
             <p14:sldId id="262"/>
           </p14:sldIdLst>
         </p14:section>
-        <p14:section name="Missions" id="{d0dea874-48c0-cc36-e47b-dc9c0b2fc399}">
+        <p14:section name="Missions" id="{f1567f55-76ef-eee9-df11-be053c171182}">
           <p14:sldIdLst>
             <p14:sldId id="263"/>
             <p14:sldId id="264"/>
@@ -163,7 +163,7 @@
             <p14:sldId id="271"/>
           </p14:sldIdLst>
         </p14:section>
-        <p14:section name="Project 1" id="{ebd9fcf5-e568-fa8c-b244-113a28787204}">
+        <p14:section name="Project 1" id="{0a049bc1-7bab-b754-dd0a-938dc34b7f16}">
           <p14:sldIdLst>
             <p14:sldId id="272"/>
             <p14:sldId id="273"/>
@@ -175,7 +175,7 @@
             <p14:sldId id="279"/>
           </p14:sldIdLst>
         </p14:section>
-        <p14:section name="Project 2" id="{5b2c8797-17f2-85ef-3dda-2850da8e7002}">
+        <p14:section name="Project 2" id="{ed0185fa-3b01-1045-fde1-86c4e3acc271}">
           <p14:sldIdLst>
             <p14:sldId id="280"/>
             <p14:sldId id="281"/>
@@ -186,7 +186,7 @@
             <p14:sldId id="286"/>
           </p14:sldIdLst>
         </p14:section>
-        <p14:section name="Closing" id="{2be66e3a-af7f-7a83-da9c-91d8e1429c18}">
+        <p14:section name="Closing" id="{5387f475-53cd-0ea6-b75a-2e02d34b31e4}">
           <p14:sldIdLst>
             <p14:sldId id="287"/>
             <p14:sldId id="288"/>
@@ -24197,6 +24197,133 @@
                 <a:cs typeface="Arial" pitchFamily="34" charset="-120"/>
               </a:rPr>
               <a:t>https://github.com/cx-guilherme-pinto/workshop-claude</a:t>
+            </a:r>
+            <a:endParaRPr lang="en-US" sz="2400" dirty="0"/>
+          </a:p>
+        </p:txBody>
+      </p:sp>
+      <p:sp>
+        <p:nvSpPr>
+          <p:cNvPr id="5" name="feedback-card"/>
+          <p:cNvSpPr/>
+          <p:nvPr/>
+        </p:nvSpPr>
+        <p:spPr>
+          <a:xfrm>
+            <a:off x="2735428" y="548640"/>
+            <a:ext cx="2377440" cy="2377440"/>
+          </a:xfrm>
+          <a:prstGeom prst="rect">
+            <a:avLst/>
+          </a:prstGeom>
+          <a:solidFill>
+            <a:srgbClr val="FFFFFF"/>
+          </a:solidFill>
+          <a:ln w="12700">
+            <a:solidFill>
+              <a:srgbClr val="FFFFFF"/>
+            </a:solidFill>
+            <a:prstDash val="solid"/>
+          </a:ln>
+        </p:spPr>
+      </p:sp>
+      <p:pic>
+        <p:nvPicPr>
+          <p:cNvPr id="6" name="feedback-qr" descr="https://forms.cloud.microsoft/r/qMtc41Gg32">    </p:cNvPr>
+          <p:cNvPicPr>
+            <a:picLocks noChangeAspect="1"/>
+          </p:cNvPicPr>
+          <p:nvPr/>
+        </p:nvPicPr>
+        <p:blipFill>
+          <a:blip r:embed="rId1"/>
+          <a:stretch>
+            <a:fillRect/>
+          </a:stretch>
+        </p:blipFill>
+        <p:spPr>
+          <a:xfrm>
+            <a:off x="2872588" y="685800"/>
+            <a:ext cx="2103120" cy="2103120"/>
+          </a:xfrm>
+          <a:prstGeom prst="rect">
+            <a:avLst/>
+          </a:prstGeom>
+        </p:spPr>
+      </p:pic>
+      <p:sp>
+        <p:nvSpPr>
+          <p:cNvPr id="7" name="feedback-label"/>
+          <p:cNvSpPr txBox="1"/>
+          <p:nvPr/>
+        </p:nvSpPr>
+        <p:spPr>
+          <a:xfrm>
+            <a:off x="5432908" y="1051560"/>
+            <a:ext cx="4023360" cy="594360"/>
+          </a:xfrm>
+          <a:prstGeom prst="rect">
+            <a:avLst/>
+          </a:prstGeom>
+          <a:noFill/>
+          <a:ln/>
+        </p:spPr>
+        <p:txBody>
+          <a:bodyPr wrap="none" lIns="0" tIns="0" rIns="0" bIns="0" rtlCol="0" anchor="t"/>
+          <a:lstStyle/>
+          <a:p>
+            <a:pPr indent="0" marL="0">
+              <a:buNone/>
+            </a:pPr>
+            <a:r>
+              <a:rPr lang="en-US" sz="3200" b="1" dirty="0">
+                <a:solidFill>
+                  <a:srgbClr val="F25928"/>
+                </a:solidFill>
+                <a:latin typeface="Founders Grotesk Medium" pitchFamily="34" charset="0"/>
+                <a:ea typeface="Founders Grotesk Medium" pitchFamily="34" charset="-122"/>
+                <a:cs typeface="Founders Grotesk Medium" pitchFamily="34" charset="-120"/>
+              </a:rPr>
+              <a:t>Rate the workshop</a:t>
+            </a:r>
+            <a:endParaRPr lang="en-US" sz="3200" dirty="0"/>
+          </a:p>
+        </p:txBody>
+      </p:sp>
+      <p:sp>
+        <p:nvSpPr>
+          <p:cNvPr id="8" name="feedback-url"/>
+          <p:cNvSpPr txBox="1"/>
+          <p:nvPr/>
+        </p:nvSpPr>
+        <p:spPr>
+          <a:xfrm>
+            <a:off x="5432908" y="1737360"/>
+            <a:ext cx="4572000" cy="457200"/>
+          </a:xfrm>
+          <a:prstGeom prst="rect">
+            <a:avLst/>
+          </a:prstGeom>
+          <a:noFill/>
+          <a:ln/>
+        </p:spPr>
+        <p:txBody>
+          <a:bodyPr wrap="none" lIns="0" tIns="0" rIns="0" bIns="0" rtlCol="0" anchor="t"/>
+          <a:lstStyle/>
+          <a:p>
+            <a:pPr indent="0" marL="0">
+              <a:buNone/>
+            </a:pPr>
+            <a:r>
+              <a:rPr lang="en-US" sz="2400" dirty="0">
+                <a:solidFill>
+                  <a:srgbClr val="B9AEDB"/>
+                </a:solidFill>
+                <a:latin typeface="Arial" pitchFamily="34" charset="0"/>
+                <a:ea typeface="Arial" pitchFamily="34" charset="-122"/>
+                <a:cs typeface="Arial" pitchFamily="34" charset="-120"/>
+              </a:rPr>
+              <a:t>forms.cloud.microsoft/r/qMtc41Gg32</a:t>
             </a:r>
             <a:endParaRPr lang="en-US" sz="2400" dirty="0"/>
           </a:p>

</xml_diff>